<commit_message>
SaveGame is now two step process with object references being supported now.
</commit_message>
<xml_diff>
--- a/Documents/Object Property Design and Binding.pptx
+++ b/Documents/Object Property Design and Binding.pptx
@@ -18015,7 +18015,9 @@
         </p:nvSpPr>
         <p:spPr/>
         <p:txBody>
-          <a:bodyPr/>
+          <a:bodyPr>
+            <a:normAutofit fontScale="85000" lnSpcReduction="20000"/>
+          </a:bodyPr>
           <a:lstStyle/>
           <a:p>
             <a:pPr marL="0" indent="0">
@@ -18055,6 +18057,32 @@
               <a:rPr lang="en-US" dirty="0"/>
               <a:t>The game object declares the singleton repository as a property to prevent it from being serialized.</a:t>
             </a:r>
+          </a:p>
+          <a:p>
+            <a:pPr marL="0" indent="0">
+              <a:buNone/>
+            </a:pPr>
+            <a:r>
+              <a:rPr lang="en-US" i="1" dirty="0">
+                <a:highlight>
+                  <a:srgbClr val="FFFF00"/>
+                </a:highlight>
+              </a:rPr>
+              <a:t>Because properties are ignored, there is an issue where a property may have state data that is ignored.  Also, interfaces can only be implemented with properties.  The Attribute has an Index property that needs to be rehydrated.  If the game configuration is loaded in a different order, the read only attribute sets will </a:t>
+            </a:r>
+            <a:r>
+              <a:rPr lang="en-US" i="1">
+                <a:highlight>
+                  <a:srgbClr val="FFFF00"/>
+                </a:highlight>
+              </a:rPr>
+              <a:t>be confused.</a:t>
+            </a:r>
+            <a:endParaRPr lang="en-US" i="1" dirty="0">
+              <a:highlight>
+                <a:srgbClr val="FFFF00"/>
+              </a:highlight>
+            </a:endParaRPr>
           </a:p>
         </p:txBody>
       </p:sp>

</xml_diff>

<commit_message>
Added a handful of XML comments.
</commit_message>
<xml_diff>
--- a/Documents/Object Property Design and Binding.pptx
+++ b/Documents/Object Property Design and Binding.pptx
@@ -21375,6 +21375,104 @@
           </a:fontRef>
         </p:style>
       </p:cxnSp>
+      <p:sp>
+        <p:nvSpPr>
+          <p:cNvPr id="3" name="Rectangle 2">
+            <a:extLst>
+              <a:ext uri="{FF2B5EF4-FFF2-40B4-BE49-F238E27FC236}">
+                <a16:creationId xmlns:a16="http://schemas.microsoft.com/office/drawing/2014/main" id="{3D324C7A-496F-507F-29A0-E21C4B5C2F92}"/>
+              </a:ext>
+            </a:extLst>
+          </p:cNvPr>
+          <p:cNvSpPr/>
+          <p:nvPr/>
+        </p:nvSpPr>
+        <p:spPr>
+          <a:xfrm>
+            <a:off x="1029275" y="1690688"/>
+            <a:ext cx="1094678" cy="361407"/>
+          </a:xfrm>
+          <a:prstGeom prst="rect">
+            <a:avLst/>
+          </a:prstGeom>
+        </p:spPr>
+        <p:style>
+          <a:lnRef idx="2">
+            <a:schemeClr val="accent1">
+              <a:shade val="15000"/>
+            </a:schemeClr>
+          </a:lnRef>
+          <a:fillRef idx="1">
+            <a:schemeClr val="accent1"/>
+          </a:fillRef>
+          <a:effectRef idx="0">
+            <a:schemeClr val="accent1"/>
+          </a:effectRef>
+          <a:fontRef idx="minor">
+            <a:schemeClr val="lt1"/>
+          </a:fontRef>
+        </p:style>
+        <p:txBody>
+          <a:bodyPr rtlCol="0" anchor="ctr"/>
+          <a:lstStyle/>
+          <a:p>
+            <a:pPr algn="ctr"/>
+            <a:r>
+              <a:rPr lang="en-US" sz="1000" dirty="0"/>
+              <a:t>Expression Parser</a:t>
+            </a:r>
+          </a:p>
+        </p:txBody>
+      </p:sp>
+      <p:sp>
+        <p:nvSpPr>
+          <p:cNvPr id="11" name="Rectangle 10">
+            <a:extLst>
+              <a:ext uri="{FF2B5EF4-FFF2-40B4-BE49-F238E27FC236}">
+                <a16:creationId xmlns:a16="http://schemas.microsoft.com/office/drawing/2014/main" id="{850E8258-A869-11D7-D1BF-400A5C94EF93}"/>
+              </a:ext>
+            </a:extLst>
+          </p:cNvPr>
+          <p:cNvSpPr/>
+          <p:nvPr/>
+        </p:nvSpPr>
+        <p:spPr>
+          <a:xfrm>
+            <a:off x="1029275" y="2217508"/>
+            <a:ext cx="1094678" cy="361407"/>
+          </a:xfrm>
+          <a:prstGeom prst="rect">
+            <a:avLst/>
+          </a:prstGeom>
+        </p:spPr>
+        <p:style>
+          <a:lnRef idx="2">
+            <a:schemeClr val="accent1">
+              <a:shade val="15000"/>
+            </a:schemeClr>
+          </a:lnRef>
+          <a:fillRef idx="1">
+            <a:schemeClr val="accent1"/>
+          </a:fillRef>
+          <a:effectRef idx="0">
+            <a:schemeClr val="accent1"/>
+          </a:effectRef>
+          <a:fontRef idx="minor">
+            <a:schemeClr val="lt1"/>
+          </a:fontRef>
+        </p:style>
+        <p:txBody>
+          <a:bodyPr rtlCol="0" anchor="ctr"/>
+          <a:lstStyle/>
+          <a:p>
+            <a:pPr algn="ctr"/>
+            <a:r>
+              <a:rPr lang="en-US" sz="1000" dirty="0"/>
+              <a:t>Parse Language</a:t>
+            </a:r>
+          </a:p>
+        </p:txBody>
+      </p:sp>
     </p:spTree>
     <p:extLst>
       <p:ext uri="{BB962C8B-B14F-4D97-AF65-F5344CB8AC3E}">

</xml_diff>

<commit_message>
Avalonia project added.  Working but slow.  Lots of updates are needed.
</commit_message>
<xml_diff>
--- a/Documents/Object Property Design and Binding.pptx
+++ b/Documents/Object Property Design and Binding.pptx
@@ -305,7 +305,7 @@
           <a:p>
             <a:fld id="{E7AEA4B1-7707-49BB-9265-EAC029350772}" type="datetimeFigureOut">
               <a:rPr lang="en-US" smtClean="0"/>
-              <a:t>6/12/2026</a:t>
+              <a:t>6/13/2026</a:t>
             </a:fld>
             <a:endParaRPr lang="en-US"/>
           </a:p>
@@ -503,7 +503,7 @@
           <a:p>
             <a:fld id="{E7AEA4B1-7707-49BB-9265-EAC029350772}" type="datetimeFigureOut">
               <a:rPr lang="en-US" smtClean="0"/>
-              <a:t>6/12/2026</a:t>
+              <a:t>6/13/2026</a:t>
             </a:fld>
             <a:endParaRPr lang="en-US"/>
           </a:p>
@@ -711,7 +711,7 @@
           <a:p>
             <a:fld id="{E7AEA4B1-7707-49BB-9265-EAC029350772}" type="datetimeFigureOut">
               <a:rPr lang="en-US" smtClean="0"/>
-              <a:t>6/12/2026</a:t>
+              <a:t>6/13/2026</a:t>
             </a:fld>
             <a:endParaRPr lang="en-US"/>
           </a:p>
@@ -909,7 +909,7 @@
           <a:p>
             <a:fld id="{E7AEA4B1-7707-49BB-9265-EAC029350772}" type="datetimeFigureOut">
               <a:rPr lang="en-US" smtClean="0"/>
-              <a:t>6/12/2026</a:t>
+              <a:t>6/13/2026</a:t>
             </a:fld>
             <a:endParaRPr lang="en-US"/>
           </a:p>
@@ -1184,7 +1184,7 @@
           <a:p>
             <a:fld id="{E7AEA4B1-7707-49BB-9265-EAC029350772}" type="datetimeFigureOut">
               <a:rPr lang="en-US" smtClean="0"/>
-              <a:t>6/12/2026</a:t>
+              <a:t>6/13/2026</a:t>
             </a:fld>
             <a:endParaRPr lang="en-US"/>
           </a:p>
@@ -1449,7 +1449,7 @@
           <a:p>
             <a:fld id="{E7AEA4B1-7707-49BB-9265-EAC029350772}" type="datetimeFigureOut">
               <a:rPr lang="en-US" smtClean="0"/>
-              <a:t>6/12/2026</a:t>
+              <a:t>6/13/2026</a:t>
             </a:fld>
             <a:endParaRPr lang="en-US"/>
           </a:p>
@@ -1861,7 +1861,7 @@
           <a:p>
             <a:fld id="{E7AEA4B1-7707-49BB-9265-EAC029350772}" type="datetimeFigureOut">
               <a:rPr lang="en-US" smtClean="0"/>
-              <a:t>6/12/2026</a:t>
+              <a:t>6/13/2026</a:t>
             </a:fld>
             <a:endParaRPr lang="en-US"/>
           </a:p>
@@ -2002,7 +2002,7 @@
           <a:p>
             <a:fld id="{E7AEA4B1-7707-49BB-9265-EAC029350772}" type="datetimeFigureOut">
               <a:rPr lang="en-US" smtClean="0"/>
-              <a:t>6/12/2026</a:t>
+              <a:t>6/13/2026</a:t>
             </a:fld>
             <a:endParaRPr lang="en-US"/>
           </a:p>
@@ -2115,7 +2115,7 @@
           <a:p>
             <a:fld id="{E7AEA4B1-7707-49BB-9265-EAC029350772}" type="datetimeFigureOut">
               <a:rPr lang="en-US" smtClean="0"/>
-              <a:t>6/12/2026</a:t>
+              <a:t>6/13/2026</a:t>
             </a:fld>
             <a:endParaRPr lang="en-US"/>
           </a:p>
@@ -2426,7 +2426,7 @@
           <a:p>
             <a:fld id="{E7AEA4B1-7707-49BB-9265-EAC029350772}" type="datetimeFigureOut">
               <a:rPr lang="en-US" smtClean="0"/>
-              <a:t>6/12/2026</a:t>
+              <a:t>6/13/2026</a:t>
             </a:fld>
             <a:endParaRPr lang="en-US"/>
           </a:p>
@@ -2714,7 +2714,7 @@
           <a:p>
             <a:fld id="{E7AEA4B1-7707-49BB-9265-EAC029350772}" type="datetimeFigureOut">
               <a:rPr lang="en-US" smtClean="0"/>
-              <a:t>6/12/2026</a:t>
+              <a:t>6/13/2026</a:t>
             </a:fld>
             <a:endParaRPr lang="en-US"/>
           </a:p>
@@ -2955,7 +2955,7 @@
           <a:p>
             <a:fld id="{E7AEA4B1-7707-49BB-9265-EAC029350772}" type="datetimeFigureOut">
               <a:rPr lang="en-US" smtClean="0"/>
-              <a:t>6/12/2026</a:t>
+              <a:t>6/13/2026</a:t>
             </a:fld>
             <a:endParaRPr lang="en-US"/>
           </a:p>
@@ -12366,8 +12366,43 @@
               <a:t>wget</a:t>
             </a:r>
             <a:r>
-              <a:rPr lang="en-US"/>
+              <a:rPr lang="en-US" dirty="0"/>
               <a:t> dotnet-install.sh)</a:t>
+            </a:r>
+          </a:p>
+          <a:p>
+            <a:pPr marL="514350" indent="-514350">
+              <a:buFont typeface="+mj-lt"/>
+              <a:buAutoNum type="arabicPeriod"/>
+            </a:pPr>
+            <a:r>
+              <a:rPr lang="en-US" dirty="0"/>
+              <a:t>Publish the game as a native single file </a:t>
+            </a:r>
+            <a:r>
+              <a:rPr lang="en-US" dirty="0" err="1"/>
+              <a:t>linux</a:t>
+            </a:r>
+            <a:r>
+              <a:rPr lang="en-US" dirty="0"/>
+              <a:t> executable:</a:t>
+            </a:r>
+          </a:p>
+          <a:p>
+            <a:pPr marL="0" indent="0">
+              <a:buNone/>
+            </a:pPr>
+            <a:r>
+              <a:rPr lang="en-US" dirty="0"/>
+              <a:t>dotnet publish -c Debug -r linux-x64 --self-contained true -</a:t>
+            </a:r>
+            <a:r>
+              <a:rPr lang="en-US" dirty="0" err="1"/>
+              <a:t>p:PublishSingleFile</a:t>
+            </a:r>
+            <a:r>
+              <a:rPr lang="en-US" dirty="0"/>
+              <a:t>=true</a:t>
             </a:r>
           </a:p>
           <a:p>

</xml_diff>